<commit_message>
Complete final RPD repository audit
</commit_message>
<xml_diff>
--- a/docs/attachments/course-presentation.pptx
+++ b/docs/attachments/course-presentation.pptx
@@ -2,20 +2,20 @@
 <file path=ppt/presentation.xml><?xml version="1.0" encoding="utf-8"?>
 <p:presentation xmlns:p="http://schemas.openxmlformats.org/presentationml/2006/main">
   <p:sldMasterIdLst>
-    <p:sldMasterId xmlns:r="http://schemas.openxmlformats.org/officeDocument/2006/relationships" id="2147483648" r:id="R7f9ab182b30a41d1"/>
+    <p:sldMasterId xmlns:r="http://schemas.openxmlformats.org/officeDocument/2006/relationships" id="2147483648" r:id="R4ef3f896e9154a14"/>
   </p:sldMasterIdLst>
   <p:notesMasterIdLst>
-    <p:notesMasterId xmlns:r="http://schemas.openxmlformats.org/officeDocument/2006/relationships" r:id="R76f7191db9b4415d"/>
+    <p:notesMasterId xmlns:r="http://schemas.openxmlformats.org/officeDocument/2006/relationships" r:id="R11042141b28441dd"/>
   </p:notesMasterIdLst>
   <p:sldIdLst>
-    <p:sldId xmlns:r="http://schemas.openxmlformats.org/officeDocument/2006/relationships" id="256" r:id="Ra2ee3ed8cb0648c2"/>
-    <p:sldId xmlns:r="http://schemas.openxmlformats.org/officeDocument/2006/relationships" id="257" r:id="R815908307fa249ab"/>
-    <p:sldId xmlns:r="http://schemas.openxmlformats.org/officeDocument/2006/relationships" id="258" r:id="Rcef34312a89e45be"/>
-    <p:sldId xmlns:r="http://schemas.openxmlformats.org/officeDocument/2006/relationships" id="259" r:id="Ra9b125c4af5c428f"/>
-    <p:sldId xmlns:r="http://schemas.openxmlformats.org/officeDocument/2006/relationships" id="260" r:id="R4d3fdee1d7b14e7c"/>
-    <p:sldId xmlns:r="http://schemas.openxmlformats.org/officeDocument/2006/relationships" id="261" r:id="R29e1d2b530094fd9"/>
-    <p:sldId xmlns:r="http://schemas.openxmlformats.org/officeDocument/2006/relationships" id="262" r:id="Rda30826abadd4723"/>
-    <p:sldId xmlns:r="http://schemas.openxmlformats.org/officeDocument/2006/relationships" id="263" r:id="R309810a60e11494d"/>
+    <p:sldId xmlns:r="http://schemas.openxmlformats.org/officeDocument/2006/relationships" id="256" r:id="R2ac316849b824ae4"/>
+    <p:sldId xmlns:r="http://schemas.openxmlformats.org/officeDocument/2006/relationships" id="257" r:id="R9bf210ce6f814561"/>
+    <p:sldId xmlns:r="http://schemas.openxmlformats.org/officeDocument/2006/relationships" id="258" r:id="R76e5a0f7618a4c55"/>
+    <p:sldId xmlns:r="http://schemas.openxmlformats.org/officeDocument/2006/relationships" id="259" r:id="Rf41bb2cca9db4bb9"/>
+    <p:sldId xmlns:r="http://schemas.openxmlformats.org/officeDocument/2006/relationships" id="260" r:id="R4a53da056c804312"/>
+    <p:sldId xmlns:r="http://schemas.openxmlformats.org/officeDocument/2006/relationships" id="261" r:id="R6a32b943e51d4313"/>
+    <p:sldId xmlns:r="http://schemas.openxmlformats.org/officeDocument/2006/relationships" id="262" r:id="Ra87c81a16c444023"/>
+    <p:sldId xmlns:r="http://schemas.openxmlformats.org/officeDocument/2006/relationships" id="263" r:id="Rc9d0b0d2b7a4449b"/>
   </p:sldIdLst>
   <p:sldSz cx="12192000" cy="6858000"/>
   <p:notesSz cx="6858000" cy="9144000"/>
@@ -3886,17 +3886,17 @@
   </p:cSld>
   <p:clrMap bg1="lt1" tx1="dk1" bg2="lt2" tx2="dk2" accent1="accent1" accent2="accent2" accent3="accent3" accent4="accent4" accent5="accent5" accent6="accent6" hlink="hlink" folHlink="folHlink"/>
   <p:sldLayoutIdLst>
-    <p:sldLayoutId xmlns:r="http://schemas.openxmlformats.org/officeDocument/2006/relationships" id="2147483649" r:id="R87670581ce954bf1"/>
-    <p:sldLayoutId xmlns:r="http://schemas.openxmlformats.org/officeDocument/2006/relationships" id="2147483650" r:id="R7f5886254eff4a86"/>
-    <p:sldLayoutId xmlns:r="http://schemas.openxmlformats.org/officeDocument/2006/relationships" id="2147483651" r:id="Rfa2e0a1bc3914654"/>
-    <p:sldLayoutId xmlns:r="http://schemas.openxmlformats.org/officeDocument/2006/relationships" id="2147483652" r:id="Re709cf3a49fa436d"/>
-    <p:sldLayoutId xmlns:r="http://schemas.openxmlformats.org/officeDocument/2006/relationships" id="2147483653" r:id="R81ecc592ee594dba"/>
-    <p:sldLayoutId xmlns:r="http://schemas.openxmlformats.org/officeDocument/2006/relationships" id="2147483654" r:id="R488818df3f874a71"/>
-    <p:sldLayoutId xmlns:r="http://schemas.openxmlformats.org/officeDocument/2006/relationships" id="2147483655" r:id="R1d489dfaff734264"/>
-    <p:sldLayoutId xmlns:r="http://schemas.openxmlformats.org/officeDocument/2006/relationships" id="2147483656" r:id="Rafdda08d17cf4fa7"/>
-    <p:sldLayoutId xmlns:r="http://schemas.openxmlformats.org/officeDocument/2006/relationships" id="2147483657" r:id="R604a903fa2494966"/>
-    <p:sldLayoutId xmlns:r="http://schemas.openxmlformats.org/officeDocument/2006/relationships" id="2147483658" r:id="R91e4c2bd40774ed5"/>
-    <p:sldLayoutId xmlns:r="http://schemas.openxmlformats.org/officeDocument/2006/relationships" id="2147483659" r:id="Rd44da8e7720c4440"/>
+    <p:sldLayoutId xmlns:r="http://schemas.openxmlformats.org/officeDocument/2006/relationships" id="2147483649" r:id="R8161027549ad4636"/>
+    <p:sldLayoutId xmlns:r="http://schemas.openxmlformats.org/officeDocument/2006/relationships" id="2147483650" r:id="Rbc8fc06e89474604"/>
+    <p:sldLayoutId xmlns:r="http://schemas.openxmlformats.org/officeDocument/2006/relationships" id="2147483651" r:id="R49842714f82140b7"/>
+    <p:sldLayoutId xmlns:r="http://schemas.openxmlformats.org/officeDocument/2006/relationships" id="2147483652" r:id="Rc9463c864ce948dc"/>
+    <p:sldLayoutId xmlns:r="http://schemas.openxmlformats.org/officeDocument/2006/relationships" id="2147483653" r:id="R7fb3c2299c8a4826"/>
+    <p:sldLayoutId xmlns:r="http://schemas.openxmlformats.org/officeDocument/2006/relationships" id="2147483654" r:id="R54671e5191ed45cb"/>
+    <p:sldLayoutId xmlns:r="http://schemas.openxmlformats.org/officeDocument/2006/relationships" id="2147483655" r:id="R0dca9fc27139455a"/>
+    <p:sldLayoutId xmlns:r="http://schemas.openxmlformats.org/officeDocument/2006/relationships" id="2147483656" r:id="R7d67acdf00b24c9a"/>
+    <p:sldLayoutId xmlns:r="http://schemas.openxmlformats.org/officeDocument/2006/relationships" id="2147483657" r:id="R2ab6cab818eb4aa7"/>
+    <p:sldLayoutId xmlns:r="http://schemas.openxmlformats.org/officeDocument/2006/relationships" id="2147483658" r:id="R7739865dff5846d4"/>
+    <p:sldLayoutId xmlns:r="http://schemas.openxmlformats.org/officeDocument/2006/relationships" id="2147483659" r:id="R56ec6195da8946dc"/>
   </p:sldLayoutIdLst>
   <p:txStyles>
     <p:titleStyle>
@@ -4593,73 +4593,7 @@
                 <a:ea typeface="Aptos"/>
                 <a:cs typeface="Aptos"/>
               </a:rPr>
-              <a:t>Проект</a:t>
-            </a:r>
-            <a:r>
-              <a:rPr sz="1800" b="0">
-                <a:solidFill>
-                  <a:srgbClr val="202D37"/>
-                </a:solidFill>
-                <a:latin typeface="Aptos"/>
-                <a:ea typeface="Aptos"/>
-                <a:cs typeface="Aptos"/>
-              </a:rPr>
-              <a:t> </a:t>
-            </a:r>
-            <a:r>
-              <a:rPr sz="1800" b="0">
-                <a:solidFill>
-                  <a:srgbClr val="202D37"/>
-                </a:solidFill>
-                <a:latin typeface="Aptos"/>
-                <a:ea typeface="Aptos"/>
-                <a:cs typeface="Aptos"/>
-              </a:rPr>
-              <a:t>РПД</a:t>
-            </a:r>
-            <a:r>
-              <a:rPr sz="1800" b="0">
-                <a:solidFill>
-                  <a:srgbClr val="202D37"/>
-                </a:solidFill>
-                <a:latin typeface="Aptos"/>
-                <a:ea typeface="Aptos"/>
-                <a:cs typeface="Aptos"/>
-              </a:rPr>
-              <a:t> </a:t>
-            </a:r>
-            <a:r>
-              <a:rPr sz="1800" b="0">
-                <a:solidFill>
-                  <a:srgbClr val="202D37"/>
-                </a:solidFill>
-                <a:latin typeface="Aptos"/>
-                <a:ea typeface="Aptos"/>
-                <a:cs typeface="Aptos"/>
-              </a:rPr>
-              <a:t>для</a:t>
-            </a:r>
-            <a:r>
-              <a:rPr sz="1800" b="0">
-                <a:solidFill>
-                  <a:srgbClr val="202D37"/>
-                </a:solidFill>
-                <a:latin typeface="Aptos"/>
-                <a:ea typeface="Aptos"/>
-                <a:cs typeface="Aptos"/>
-              </a:rPr>
-              <a:t> </a:t>
-            </a:r>
-            <a:r>
-              <a:rPr sz="1800" b="0">
-                <a:solidFill>
-                  <a:srgbClr val="202D37"/>
-                </a:solidFill>
-                <a:latin typeface="Aptos"/>
-                <a:ea typeface="Aptos"/>
-                <a:cs typeface="Aptos"/>
-              </a:rPr>
-              <a:t>6ого семестра</a:t>
+              <a:t>Проект РПД · 6-й семестр</a:t>
             </a:r>
           </a:p>
         </p:txBody>
@@ -4746,7 +4680,7 @@
           <a:p xmlns:a="http://schemas.openxmlformats.org/drawingml/2006/main">
             <a:r>
               <a:rPr sz="1000" b="1"/>
-              <a:t>Прикладная математика и информатика» (01.03.02)</a:t>
+              <a:t>01.03.02 · Прикладная математика и информатика</a:t>
             </a:r>
           </a:p>
         </p:txBody>
@@ -8876,161 +8810,7 @@
                 <a:ea typeface="Aptos"/>
                 <a:cs typeface="Aptos"/>
               </a:rPr>
-              <a:t>Выбирает</a:t>
-            </a:r>
-            <a:r>
-              <a:rPr sz="1300" b="0">
-                <a:solidFill>
-                  <a:srgbClr val="202D37"/>
-                </a:solidFill>
-                <a:latin typeface="Aptos"/>
-                <a:ea typeface="Aptos"/>
-                <a:cs typeface="Aptos"/>
-              </a:rPr>
-              <a:t> </a:t>
-            </a:r>
-            <a:r>
-              <a:rPr sz="1300" b="0">
-                <a:solidFill>
-                  <a:srgbClr val="202D37"/>
-                </a:solidFill>
-                <a:latin typeface="Aptos"/>
-                <a:ea typeface="Aptos"/>
-                <a:cs typeface="Aptos"/>
-              </a:rPr>
-              <a:t>тип</a:t>
-            </a:r>
-            <a:r>
-              <a:rPr sz="1300" b="0">
-                <a:solidFill>
-                  <a:srgbClr val="202D37"/>
-                </a:solidFill>
-                <a:latin typeface="Aptos"/>
-                <a:ea typeface="Aptos"/>
-                <a:cs typeface="Aptos"/>
-              </a:rPr>
-              <a:t> </a:t>
-            </a:r>
-            <a:r>
-              <a:rPr sz="1300" b="0">
-                <a:solidFill>
-                  <a:srgbClr val="202D37"/>
-                </a:solidFill>
-                <a:latin typeface="Aptos"/>
-                <a:ea typeface="Aptos"/>
-                <a:cs typeface="Aptos"/>
-              </a:rPr>
-              <a:t>задачи</a:t>
-            </a:r>
-            <a:r>
-              <a:rPr sz="1300" b="0">
-                <a:solidFill>
-                  <a:srgbClr val="202D37"/>
-                </a:solidFill>
-                <a:latin typeface="Aptos"/>
-                <a:ea typeface="Aptos"/>
-                <a:cs typeface="Aptos"/>
-              </a:rPr>
-              <a:t>, </a:t>
-            </a:r>
-            <a:r>
-              <a:rPr sz="1300" b="0">
-                <a:solidFill>
-                  <a:srgbClr val="202D37"/>
-                </a:solidFill>
-                <a:latin typeface="Aptos"/>
-                <a:ea typeface="Aptos"/>
-                <a:cs typeface="Aptos"/>
-              </a:rPr>
-              <a:t>строит</a:t>
-            </a:r>
-            <a:r>
-              <a:rPr sz="1300" b="0">
-                <a:solidFill>
-                  <a:srgbClr val="202D37"/>
-                </a:solidFill>
-                <a:latin typeface="Aptos"/>
-                <a:ea typeface="Aptos"/>
-                <a:cs typeface="Aptos"/>
-              </a:rPr>
-              <a:t> </a:t>
-            </a:r>
-            <a:r>
-              <a:rPr sz="1300" b="0">
-                <a:solidFill>
-                  <a:srgbClr val="202D37"/>
-                </a:solidFill>
-                <a:latin typeface="Aptos"/>
-                <a:ea typeface="Aptos"/>
-                <a:cs typeface="Aptos"/>
-              </a:rPr>
-              <a:t>модели</a:t>
-            </a:r>
-            <a:r>
-              <a:rPr sz="1300" b="0">
-                <a:solidFill>
-                  <a:srgbClr val="202D37"/>
-                </a:solidFill>
-                <a:latin typeface="Aptos"/>
-                <a:ea typeface="Aptos"/>
-                <a:cs typeface="Aptos"/>
-              </a:rPr>
-              <a:t>, </a:t>
-            </a:r>
-            <a:r>
-              <a:rPr sz="1300" b="0">
-                <a:solidFill>
-                  <a:srgbClr val="202D37"/>
-                </a:solidFill>
-                <a:latin typeface="Aptos"/>
-                <a:ea typeface="Aptos"/>
-                <a:cs typeface="Aptos"/>
-              </a:rPr>
-              <a:t>применяет</a:t>
-            </a:r>
-            <a:r>
-              <a:rPr sz="1300" b="0">
-                <a:solidFill>
-                  <a:srgbClr val="202D37"/>
-                </a:solidFill>
-                <a:latin typeface="Aptos"/>
-                <a:ea typeface="Aptos"/>
-                <a:cs typeface="Aptos"/>
-              </a:rPr>
-              <a:t> </a:t>
-            </a:r>
-            <a:r>
-              <a:rPr sz="1300" b="0">
-                <a:solidFill>
-                  <a:srgbClr val="202D37"/>
-                </a:solidFill>
-                <a:latin typeface="Aptos"/>
-                <a:ea typeface="Aptos"/>
-                <a:cs typeface="Aptos"/>
-              </a:rPr>
-              <a:t>валидацию</a:t>
-            </a:r>
-            <a:r>
-              <a:rPr sz="1300" b="0">
-                <a:solidFill>
-                  <a:srgbClr val="202D37"/>
-                </a:solidFill>
-                <a:latin typeface="Aptos"/>
-                <a:ea typeface="Aptos"/>
-                <a:cs typeface="Aptos"/>
-              </a:rPr>
-              <a:t> и </a:t>
-            </a:r>
-            <a:r>
-              <a:rPr sz="1300" b="0">
-                <a:solidFill>
-                  <a:srgbClr val="202D37"/>
-                </a:solidFill>
-                <a:latin typeface="Aptos"/>
-                <a:ea typeface="Aptos"/>
-                <a:cs typeface="Aptos"/>
-              </a:rPr>
-              <a:t>метрики</a:t>
+              <a:t>Выбирает тип задачи и модели, применяет валидацию и метрики.</a:t>
             </a:r>
           </a:p>
         </p:txBody>
@@ -9286,7 +9066,7 @@
                 <a:ea typeface="Aptos"/>
                 <a:cs typeface="Aptos"/>
               </a:rPr>
-              <a:t>Python остаётся основным инструментом выполнения заданий, но не выделяется в отдельную защищаемую компетенцию.</a:t>
+              <a:t>BD-1: курс формирует уровень С; уровень П требует нескольких независимых работ в последующих элементах программы.</a:t>
             </a:r>
           </a:p>
         </p:txBody>
@@ -11358,194 +11138,7 @@
                 <a:ea typeface="Aptos"/>
                 <a:cs typeface="Aptos"/>
               </a:rPr>
-              <a:t>Выявляет</a:t>
-            </a:r>
-            <a:r>
-              <a:rPr sz="1000">
-                <a:solidFill>
-                  <a:srgbClr val="202D37"/>
-                </a:solidFill>
-                <a:latin typeface="Aptos"/>
-                <a:ea typeface="Aptos"/>
-                <a:cs typeface="Aptos"/>
-              </a:rPr>
-              <a:t> </a:t>
-            </a:r>
-            <a:r>
-              <a:rPr sz="1000">
-                <a:solidFill>
-                  <a:srgbClr val="202D37"/>
-                </a:solidFill>
-                <a:latin typeface="Aptos"/>
-                <a:ea typeface="Aptos"/>
-                <a:cs typeface="Aptos"/>
-              </a:rPr>
-              <a:t>пропуски</a:t>
-            </a:r>
-            <a:r>
-              <a:rPr sz="1000">
-                <a:solidFill>
-                  <a:srgbClr val="202D37"/>
-                </a:solidFill>
-                <a:latin typeface="Aptos"/>
-                <a:ea typeface="Aptos"/>
-                <a:cs typeface="Aptos"/>
-              </a:rPr>
-              <a:t>, </a:t>
-            </a:r>
-            <a:r>
-              <a:rPr sz="1000">
-                <a:solidFill>
-                  <a:srgbClr val="202D37"/>
-                </a:solidFill>
-                <a:latin typeface="Aptos"/>
-                <a:ea typeface="Aptos"/>
-                <a:cs typeface="Aptos"/>
-              </a:rPr>
-              <a:t>дубликаты</a:t>
-            </a:r>
-            <a:r>
-              <a:rPr sz="1000">
-                <a:solidFill>
-                  <a:srgbClr val="202D37"/>
-                </a:solidFill>
-                <a:latin typeface="Aptos"/>
-                <a:ea typeface="Aptos"/>
-                <a:cs typeface="Aptos"/>
-              </a:rPr>
-              <a:t>, </a:t>
-            </a:r>
-            <a:r>
-              <a:rPr sz="1000">
-                <a:solidFill>
-                  <a:srgbClr val="202D37"/>
-                </a:solidFill>
-                <a:latin typeface="Aptos"/>
-                <a:ea typeface="Aptos"/>
-                <a:cs typeface="Aptos"/>
-              </a:rPr>
-              <a:t>выбросы</a:t>
-            </a:r>
-            <a:r>
-              <a:rPr sz="1000">
-                <a:solidFill>
-                  <a:srgbClr val="202D37"/>
-                </a:solidFill>
-                <a:latin typeface="Aptos"/>
-                <a:ea typeface="Aptos"/>
-                <a:cs typeface="Aptos"/>
-              </a:rPr>
-              <a:t> и </a:t>
-            </a:r>
-            <a:r>
-              <a:rPr sz="1000">
-                <a:solidFill>
-                  <a:srgbClr val="202D37"/>
-                </a:solidFill>
-                <a:latin typeface="Aptos"/>
-                <a:ea typeface="Aptos"/>
-                <a:cs typeface="Aptos"/>
-              </a:rPr>
-              <a:t>ошибки</a:t>
-            </a:r>
-            <a:r>
-              <a:rPr sz="1000">
-                <a:solidFill>
-                  <a:srgbClr val="202D37"/>
-                </a:solidFill>
-                <a:latin typeface="Aptos"/>
-                <a:ea typeface="Aptos"/>
-                <a:cs typeface="Aptos"/>
-              </a:rPr>
-              <a:t>; </a:t>
-            </a:r>
-            <a:r>
-              <a:rPr sz="1000">
-                <a:solidFill>
-                  <a:srgbClr val="202D37"/>
-                </a:solidFill>
-                <a:latin typeface="Aptos"/>
-                <a:ea typeface="Aptos"/>
-                <a:cs typeface="Aptos"/>
-              </a:rPr>
-              <a:t>обосновывает</a:t>
-            </a:r>
-            <a:r>
-              <a:rPr sz="1000">
-                <a:solidFill>
-                  <a:srgbClr val="202D37"/>
-                </a:solidFill>
-                <a:latin typeface="Aptos"/>
-                <a:ea typeface="Aptos"/>
-                <a:cs typeface="Aptos"/>
-              </a:rPr>
-              <a:t> </a:t>
-            </a:r>
-            <a:r>
-              <a:rPr sz="1000">
-                <a:solidFill>
-                  <a:srgbClr val="202D37"/>
-                </a:solidFill>
-                <a:latin typeface="Aptos"/>
-                <a:ea typeface="Aptos"/>
-                <a:cs typeface="Aptos"/>
-              </a:rPr>
-              <a:t>выбранный</a:t>
-            </a:r>
-            <a:r>
-              <a:rPr sz="1000">
-                <a:solidFill>
-                  <a:srgbClr val="202D37"/>
-                </a:solidFill>
-                <a:latin typeface="Aptos"/>
-                <a:ea typeface="Aptos"/>
-                <a:cs typeface="Aptos"/>
-              </a:rPr>
-              <a:t> </a:t>
-            </a:r>
-            <a:r>
-              <a:rPr sz="1000">
-                <a:solidFill>
-                  <a:srgbClr val="202D37"/>
-                </a:solidFill>
-                <a:latin typeface="Aptos"/>
-                <a:ea typeface="Aptos"/>
-                <a:cs typeface="Aptos"/>
-              </a:rPr>
-              <a:t>способ</a:t>
-            </a:r>
-            <a:r>
-              <a:rPr sz="1000">
-                <a:solidFill>
-                  <a:srgbClr val="202D37"/>
-                </a:solidFill>
-                <a:latin typeface="Aptos"/>
-                <a:ea typeface="Aptos"/>
-                <a:cs typeface="Aptos"/>
-              </a:rPr>
-              <a:t> </a:t>
-            </a:r>
-            <a:r>
-              <a:rPr sz="1000">
-                <a:solidFill>
-                  <a:srgbClr val="202D37"/>
-                </a:solidFill>
-                <a:latin typeface="Aptos"/>
-                <a:ea typeface="Aptos"/>
-                <a:cs typeface="Aptos"/>
-              </a:rPr>
-              <a:t>обработки</a:t>
-            </a:r>
-            <a:r>
-              <a:rPr sz="1000">
-                <a:solidFill>
-                  <a:srgbClr val="202D37"/>
-                </a:solidFill>
-                <a:latin typeface="Aptos"/>
-                <a:ea typeface="Aptos"/>
-                <a:cs typeface="Aptos"/>
-              </a:rPr>
-              <a:t>.</a:t>
+              <a:t>Находит пропуски, дубликаты, выбросы и ошибки, обосновывает обработку.</a:t>
             </a:r>
           </a:p>
         </p:txBody>
@@ -11763,172 +11356,7 @@
                 <a:ea typeface="Aptos"/>
                 <a:cs typeface="Aptos"/>
               </a:rPr>
-              <a:t>Отбирает</a:t>
-            </a:r>
-            <a:r>
-              <a:rPr sz="1000">
-                <a:solidFill>
-                  <a:srgbClr val="202D37"/>
-                </a:solidFill>
-                <a:latin typeface="Aptos"/>
-                <a:ea typeface="Aptos"/>
-                <a:cs typeface="Aptos"/>
-              </a:rPr>
-              <a:t>, </a:t>
-            </a:r>
-            <a:r>
-              <a:rPr sz="1000">
-                <a:solidFill>
-                  <a:srgbClr val="202D37"/>
-                </a:solidFill>
-                <a:latin typeface="Aptos"/>
-                <a:ea typeface="Aptos"/>
-                <a:cs typeface="Aptos"/>
-              </a:rPr>
-              <a:t>преобразует</a:t>
-            </a:r>
-            <a:r>
-              <a:rPr sz="1000">
-                <a:solidFill>
-                  <a:srgbClr val="202D37"/>
-                </a:solidFill>
-                <a:latin typeface="Aptos"/>
-                <a:ea typeface="Aptos"/>
-                <a:cs typeface="Aptos"/>
-              </a:rPr>
-              <a:t> и </a:t>
-            </a:r>
-            <a:r>
-              <a:rPr sz="1000">
-                <a:solidFill>
-                  <a:srgbClr val="202D37"/>
-                </a:solidFill>
-                <a:latin typeface="Aptos"/>
-                <a:ea typeface="Aptos"/>
-                <a:cs typeface="Aptos"/>
-              </a:rPr>
-              <a:t>создаёт</a:t>
-            </a:r>
-            <a:r>
-              <a:rPr sz="1000">
-                <a:solidFill>
-                  <a:srgbClr val="202D37"/>
-                </a:solidFill>
-                <a:latin typeface="Aptos"/>
-                <a:ea typeface="Aptos"/>
-                <a:cs typeface="Aptos"/>
-              </a:rPr>
-              <a:t> </a:t>
-            </a:r>
-            <a:r>
-              <a:rPr sz="1000">
-                <a:solidFill>
-                  <a:srgbClr val="202D37"/>
-                </a:solidFill>
-                <a:latin typeface="Aptos"/>
-                <a:ea typeface="Aptos"/>
-                <a:cs typeface="Aptos"/>
-              </a:rPr>
-              <a:t>признаки</a:t>
-            </a:r>
-            <a:r>
-              <a:rPr sz="1000">
-                <a:solidFill>
-                  <a:srgbClr val="202D37"/>
-                </a:solidFill>
-                <a:latin typeface="Aptos"/>
-                <a:ea typeface="Aptos"/>
-                <a:cs typeface="Aptos"/>
-              </a:rPr>
-              <a:t> с </a:t>
-            </a:r>
-            <a:r>
-              <a:rPr sz="1000">
-                <a:solidFill>
-                  <a:srgbClr val="202D37"/>
-                </a:solidFill>
-                <a:latin typeface="Aptos"/>
-                <a:ea typeface="Aptos"/>
-                <a:cs typeface="Aptos"/>
-              </a:rPr>
-              <a:t>учётом</a:t>
-            </a:r>
-            <a:r>
-              <a:rPr sz="1000">
-                <a:solidFill>
-                  <a:srgbClr val="202D37"/>
-                </a:solidFill>
-                <a:latin typeface="Aptos"/>
-                <a:ea typeface="Aptos"/>
-                <a:cs typeface="Aptos"/>
-              </a:rPr>
-              <a:t> </a:t>
-            </a:r>
-            <a:r>
-              <a:rPr sz="1000">
-                <a:solidFill>
-                  <a:srgbClr val="202D37"/>
-                </a:solidFill>
-                <a:latin typeface="Aptos"/>
-                <a:ea typeface="Aptos"/>
-                <a:cs typeface="Aptos"/>
-              </a:rPr>
-              <a:t>содержания</a:t>
-            </a:r>
-            <a:r>
-              <a:rPr sz="1000">
-                <a:solidFill>
-                  <a:srgbClr val="202D37"/>
-                </a:solidFill>
-                <a:latin typeface="Aptos"/>
-                <a:ea typeface="Aptos"/>
-                <a:cs typeface="Aptos"/>
-              </a:rPr>
-              <a:t> </a:t>
-            </a:r>
-            <a:r>
-              <a:rPr sz="1000">
-                <a:solidFill>
-                  <a:srgbClr val="202D37"/>
-                </a:solidFill>
-                <a:latin typeface="Aptos"/>
-                <a:ea typeface="Aptos"/>
-                <a:cs typeface="Aptos"/>
-              </a:rPr>
-              <a:t>прикладной</a:t>
-            </a:r>
-            <a:r>
-              <a:rPr sz="1000">
-                <a:solidFill>
-                  <a:srgbClr val="202D37"/>
-                </a:solidFill>
-                <a:latin typeface="Aptos"/>
-                <a:ea typeface="Aptos"/>
-                <a:cs typeface="Aptos"/>
-              </a:rPr>
-              <a:t> </a:t>
-            </a:r>
-            <a:r>
-              <a:rPr sz="1000">
-                <a:solidFill>
-                  <a:srgbClr val="202D37"/>
-                </a:solidFill>
-                <a:latin typeface="Aptos"/>
-                <a:ea typeface="Aptos"/>
-                <a:cs typeface="Aptos"/>
-              </a:rPr>
-              <a:t>задачи</a:t>
-            </a:r>
-            <a:r>
-              <a:rPr sz="1000">
-                <a:solidFill>
-                  <a:srgbClr val="202D37"/>
-                </a:solidFill>
-                <a:latin typeface="Aptos"/>
-                <a:ea typeface="Aptos"/>
-                <a:cs typeface="Aptos"/>
-              </a:rPr>
-              <a:t>.</a:t>
+              <a:t>Отбирает и создаёт признаки с учётом задачи и момента их доступности.</a:t>
             </a:r>
           </a:p>
         </p:txBody>
@@ -12190,150 +11618,7 @@
                 <a:ea typeface="Aptos"/>
                 <a:cs typeface="Aptos"/>
               </a:rPr>
-              <a:t>Различает</a:t>
-            </a:r>
-            <a:r>
-              <a:rPr sz="1000">
-                <a:solidFill>
-                  <a:srgbClr val="202D37"/>
-                </a:solidFill>
-                <a:latin typeface="Aptos"/>
-                <a:ea typeface="Aptos"/>
-                <a:cs typeface="Aptos"/>
-              </a:rPr>
-              <a:t> </a:t>
-            </a:r>
-            <a:r>
-              <a:rPr sz="1000">
-                <a:solidFill>
-                  <a:srgbClr val="202D37"/>
-                </a:solidFill>
-                <a:latin typeface="Aptos"/>
-                <a:ea typeface="Aptos"/>
-                <a:cs typeface="Aptos"/>
-              </a:rPr>
-              <a:t>регрессию</a:t>
-            </a:r>
-            <a:r>
-              <a:rPr sz="1000">
-                <a:solidFill>
-                  <a:srgbClr val="202D37"/>
-                </a:solidFill>
-                <a:latin typeface="Aptos"/>
-                <a:ea typeface="Aptos"/>
-                <a:cs typeface="Aptos"/>
-              </a:rPr>
-              <a:t>, </a:t>
-            </a:r>
-            <a:r>
-              <a:rPr sz="1000">
-                <a:solidFill>
-                  <a:srgbClr val="202D37"/>
-                </a:solidFill>
-                <a:latin typeface="Aptos"/>
-                <a:ea typeface="Aptos"/>
-                <a:cs typeface="Aptos"/>
-              </a:rPr>
-              <a:t>классификацию</a:t>
-            </a:r>
-            <a:r>
-              <a:rPr sz="1000">
-                <a:solidFill>
-                  <a:srgbClr val="202D37"/>
-                </a:solidFill>
-                <a:latin typeface="Aptos"/>
-                <a:ea typeface="Aptos"/>
-                <a:cs typeface="Aptos"/>
-              </a:rPr>
-              <a:t> и </a:t>
-            </a:r>
-            <a:r>
-              <a:rPr sz="1000">
-                <a:solidFill>
-                  <a:srgbClr val="202D37"/>
-                </a:solidFill>
-                <a:latin typeface="Aptos"/>
-                <a:ea typeface="Aptos"/>
-                <a:cs typeface="Aptos"/>
-              </a:rPr>
-              <a:t>кластеризацию</a:t>
-            </a:r>
-            <a:r>
-              <a:rPr sz="1000">
-                <a:solidFill>
-                  <a:srgbClr val="202D37"/>
-                </a:solidFill>
-                <a:latin typeface="Aptos"/>
-                <a:ea typeface="Aptos"/>
-                <a:cs typeface="Aptos"/>
-              </a:rPr>
-              <a:t>; </a:t>
-            </a:r>
-            <a:r>
-              <a:rPr sz="1000">
-                <a:solidFill>
-                  <a:srgbClr val="202D37"/>
-                </a:solidFill>
-                <a:latin typeface="Aptos"/>
-                <a:ea typeface="Aptos"/>
-                <a:cs typeface="Aptos"/>
-              </a:rPr>
-              <a:t>строит</a:t>
-            </a:r>
-            <a:r>
-              <a:rPr sz="1000">
-                <a:solidFill>
-                  <a:srgbClr val="202D37"/>
-                </a:solidFill>
-                <a:latin typeface="Aptos"/>
-                <a:ea typeface="Aptos"/>
-                <a:cs typeface="Aptos"/>
-              </a:rPr>
-              <a:t> baseline и </a:t>
-            </a:r>
-            <a:r>
-              <a:rPr sz="1000">
-                <a:solidFill>
-                  <a:srgbClr val="202D37"/>
-                </a:solidFill>
-                <a:latin typeface="Aptos"/>
-                <a:ea typeface="Aptos"/>
-                <a:cs typeface="Aptos"/>
-              </a:rPr>
-              <a:t>выбирает</a:t>
-            </a:r>
-            <a:r>
-              <a:rPr sz="1000">
-                <a:solidFill>
-                  <a:srgbClr val="202D37"/>
-                </a:solidFill>
-                <a:latin typeface="Aptos"/>
-                <a:ea typeface="Aptos"/>
-                <a:cs typeface="Aptos"/>
-              </a:rPr>
-              <a:t> </a:t>
-            </a:r>
-            <a:r>
-              <a:rPr sz="1000">
-                <a:solidFill>
-                  <a:srgbClr val="202D37"/>
-                </a:solidFill>
-                <a:latin typeface="Aptos"/>
-                <a:ea typeface="Aptos"/>
-                <a:cs typeface="Aptos"/>
-              </a:rPr>
-              <a:t>подход</a:t>
-            </a:r>
-            <a:r>
-              <a:rPr sz="1000">
-                <a:solidFill>
-                  <a:srgbClr val="202D37"/>
-                </a:solidFill>
-                <a:latin typeface="Aptos"/>
-                <a:ea typeface="Aptos"/>
-                <a:cs typeface="Aptos"/>
-              </a:rPr>
-              <a:t>.</a:t>
+              <a:t>Различает регрессию, классификацию и кластеризацию, строит baseline и выбирает подход.</a:t>
             </a:r>
           </a:p>
         </p:txBody>
@@ -13000,172 +12285,7 @@
                 <a:ea typeface="Aptos"/>
                 <a:cs typeface="Aptos"/>
               </a:rPr>
-              <a:t>Выбирает</a:t>
-            </a:r>
-            <a:r>
-              <a:rPr sz="1000">
-                <a:solidFill>
-                  <a:srgbClr val="202D37"/>
-                </a:solidFill>
-                <a:latin typeface="Aptos"/>
-                <a:ea typeface="Aptos"/>
-                <a:cs typeface="Aptos"/>
-              </a:rPr>
-              <a:t> </a:t>
-            </a:r>
-            <a:r>
-              <a:rPr sz="1000">
-                <a:solidFill>
-                  <a:srgbClr val="202D37"/>
-                </a:solidFill>
-                <a:latin typeface="Aptos"/>
-                <a:ea typeface="Aptos"/>
-                <a:cs typeface="Aptos"/>
-              </a:rPr>
-              <a:t>схему</a:t>
-            </a:r>
-            <a:r>
-              <a:rPr sz="1000">
-                <a:solidFill>
-                  <a:srgbClr val="202D37"/>
-                </a:solidFill>
-                <a:latin typeface="Aptos"/>
-                <a:ea typeface="Aptos"/>
-                <a:cs typeface="Aptos"/>
-              </a:rPr>
-              <a:t> </a:t>
-            </a:r>
-            <a:r>
-              <a:rPr sz="1000">
-                <a:solidFill>
-                  <a:srgbClr val="202D37"/>
-                </a:solidFill>
-                <a:latin typeface="Aptos"/>
-                <a:ea typeface="Aptos"/>
-                <a:cs typeface="Aptos"/>
-              </a:rPr>
-              <a:t>валидации</a:t>
-            </a:r>
-            <a:r>
-              <a:rPr sz="1000">
-                <a:solidFill>
-                  <a:srgbClr val="202D37"/>
-                </a:solidFill>
-                <a:latin typeface="Aptos"/>
-                <a:ea typeface="Aptos"/>
-                <a:cs typeface="Aptos"/>
-              </a:rPr>
-              <a:t> и </a:t>
-            </a:r>
-            <a:r>
-              <a:rPr sz="1000">
-                <a:solidFill>
-                  <a:srgbClr val="202D37"/>
-                </a:solidFill>
-                <a:latin typeface="Aptos"/>
-                <a:ea typeface="Aptos"/>
-                <a:cs typeface="Aptos"/>
-              </a:rPr>
-              <a:t>метрики</a:t>
-            </a:r>
-            <a:r>
-              <a:rPr sz="1000">
-                <a:solidFill>
-                  <a:srgbClr val="202D37"/>
-                </a:solidFill>
-                <a:latin typeface="Aptos"/>
-                <a:ea typeface="Aptos"/>
-                <a:cs typeface="Aptos"/>
-              </a:rPr>
-              <a:t>, </a:t>
-            </a:r>
-            <a:r>
-              <a:rPr sz="1000">
-                <a:solidFill>
-                  <a:srgbClr val="202D37"/>
-                </a:solidFill>
-                <a:latin typeface="Aptos"/>
-                <a:ea typeface="Aptos"/>
-                <a:cs typeface="Aptos"/>
-              </a:rPr>
-              <a:t>анализирует</a:t>
-            </a:r>
-            <a:r>
-              <a:rPr sz="1000">
-                <a:solidFill>
-                  <a:srgbClr val="202D37"/>
-                </a:solidFill>
-                <a:latin typeface="Aptos"/>
-                <a:ea typeface="Aptos"/>
-                <a:cs typeface="Aptos"/>
-              </a:rPr>
-              <a:t> </a:t>
-            </a:r>
-            <a:r>
-              <a:rPr sz="1000">
-                <a:solidFill>
-                  <a:srgbClr val="202D37"/>
-                </a:solidFill>
-                <a:latin typeface="Aptos"/>
-                <a:ea typeface="Aptos"/>
-                <a:cs typeface="Aptos"/>
-              </a:rPr>
-              <a:t>переобучение</a:t>
-            </a:r>
-            <a:r>
-              <a:rPr sz="1000">
-                <a:solidFill>
-                  <a:srgbClr val="202D37"/>
-                </a:solidFill>
-                <a:latin typeface="Aptos"/>
-                <a:ea typeface="Aptos"/>
-                <a:cs typeface="Aptos"/>
-              </a:rPr>
-              <a:t>, </a:t>
-            </a:r>
-            <a:r>
-              <a:rPr sz="1000">
-                <a:solidFill>
-                  <a:srgbClr val="202D37"/>
-                </a:solidFill>
-                <a:latin typeface="Aptos"/>
-                <a:ea typeface="Aptos"/>
-                <a:cs typeface="Aptos"/>
-              </a:rPr>
-              <a:t>ошибки</a:t>
-            </a:r>
-            <a:r>
-              <a:rPr sz="1000">
-                <a:solidFill>
-                  <a:srgbClr val="202D37"/>
-                </a:solidFill>
-                <a:latin typeface="Aptos"/>
-                <a:ea typeface="Aptos"/>
-                <a:cs typeface="Aptos"/>
-              </a:rPr>
-              <a:t> и </a:t>
-            </a:r>
-            <a:r>
-              <a:rPr sz="1000">
-                <a:solidFill>
-                  <a:srgbClr val="202D37"/>
-                </a:solidFill>
-                <a:latin typeface="Aptos"/>
-                <a:ea typeface="Aptos"/>
-                <a:cs typeface="Aptos"/>
-              </a:rPr>
-              <a:t>ограничения</a:t>
-            </a:r>
-            <a:r>
-              <a:rPr sz="1000">
-                <a:solidFill>
-                  <a:srgbClr val="202D37"/>
-                </a:solidFill>
-                <a:latin typeface="Aptos"/>
-                <a:ea typeface="Aptos"/>
-                <a:cs typeface="Aptos"/>
-              </a:rPr>
-              <a:t>.</a:t>
+              <a:t>Выбирает схему валидации и метрики, разбирает ошибки и ограничения.</a:t>
             </a:r>
           </a:p>
         </p:txBody>
@@ -17481,7 +16601,7 @@
                           <a:ea typeface="Aptos"/>
                           <a:cs typeface="Aptos"/>
                         </a:rPr>
-                        <a:t>1.1; 1.2; 2.3</a:t>
+                        <a:t>1.1; 1.2, 1.3, 1.5; 2.1–2.3</a:t>
                       </a:r>
                     </a:p>
                   </a:txBody>
@@ -17693,7 +16813,7 @@
                           <a:ea typeface="Aptos"/>
                           <a:cs typeface="Aptos"/>
                         </a:rPr>
-                        <a:t>1.1; 1.2–1.5; 2.1–2.3</a:t>
+                        <a:t>1.1; 1.2, 1.3, 1.5; 2.1–2.3</a:t>
                       </a:r>
                     </a:p>
                   </a:txBody>
@@ -18294,7 +17414,7 @@
         <p:spPr>
           <a:xfrm xmlns:a="http://schemas.openxmlformats.org/drawingml/2006/main">
             <a:off x="9720000" y="1007999"/>
-            <a:ext cx="900000" cy="251999"/>
+            <a:ext cx="900000" cy="270960"/>
           </a:xfrm>
           <a:prstGeom xmlns:a="http://schemas.openxmlformats.org/drawingml/2006/main" prst="rect">
             <a:avLst/>
@@ -18322,7 +17442,7 @@
                 <a:ea typeface="Aptos"/>
                 <a:cs typeface="Aptos"/>
               </a:rPr>
-              <a:t>10%</a:t>
+              <a:t>10 б.</a:t>
             </a:r>
           </a:p>
         </p:txBody>
@@ -18447,7 +17567,7 @@
         <p:spPr>
           <a:xfrm xmlns:a="http://schemas.openxmlformats.org/drawingml/2006/main">
             <a:off x="9720000" y="1601999"/>
-            <a:ext cx="900000" cy="251999"/>
+            <a:ext cx="900000" cy="270960"/>
           </a:xfrm>
           <a:prstGeom xmlns:a="http://schemas.openxmlformats.org/drawingml/2006/main" prst="rect">
             <a:avLst/>
@@ -18475,7 +17595,7 @@
                 <a:ea typeface="Aptos"/>
                 <a:cs typeface="Aptos"/>
               </a:rPr>
-              <a:t>15%</a:t>
+              <a:t>15 б.</a:t>
             </a:r>
           </a:p>
         </p:txBody>
@@ -18600,7 +17720,7 @@
         <p:spPr>
           <a:xfrm xmlns:a="http://schemas.openxmlformats.org/drawingml/2006/main">
             <a:off x="9720000" y="2196000"/>
-            <a:ext cx="900000" cy="251999"/>
+            <a:ext cx="900000" cy="270960"/>
           </a:xfrm>
           <a:prstGeom xmlns:a="http://schemas.openxmlformats.org/drawingml/2006/main" prst="rect">
             <a:avLst/>
@@ -18628,7 +17748,7 @@
                 <a:ea typeface="Aptos"/>
                 <a:cs typeface="Aptos"/>
               </a:rPr>
-              <a:t>15%</a:t>
+              <a:t>15 б.</a:t>
             </a:r>
           </a:p>
         </p:txBody>
@@ -18753,7 +17873,7 @@
         <p:spPr>
           <a:xfrm xmlns:a="http://schemas.openxmlformats.org/drawingml/2006/main">
             <a:off x="9720000" y="2790000"/>
-            <a:ext cx="900000" cy="251999"/>
+            <a:ext cx="900000" cy="270960"/>
           </a:xfrm>
           <a:prstGeom xmlns:a="http://schemas.openxmlformats.org/drawingml/2006/main" prst="rect">
             <a:avLst/>
@@ -18781,7 +17901,7 @@
                 <a:ea typeface="Aptos"/>
                 <a:cs typeface="Aptos"/>
               </a:rPr>
-              <a:t>20%</a:t>
+              <a:t>20 б.</a:t>
             </a:r>
           </a:p>
         </p:txBody>
@@ -18906,7 +18026,7 @@
         <p:spPr>
           <a:xfrm xmlns:a="http://schemas.openxmlformats.org/drawingml/2006/main">
             <a:off x="9720000" y="3384000"/>
-            <a:ext cx="900000" cy="251999"/>
+            <a:ext cx="900000" cy="270960"/>
           </a:xfrm>
           <a:prstGeom xmlns:a="http://schemas.openxmlformats.org/drawingml/2006/main" prst="rect">
             <a:avLst/>
@@ -18934,7 +18054,7 @@
                 <a:ea typeface="Aptos"/>
                 <a:cs typeface="Aptos"/>
               </a:rPr>
-              <a:t>15%</a:t>
+              <a:t>15 б.</a:t>
             </a:r>
           </a:p>
         </p:txBody>
@@ -19059,7 +18179,7 @@
         <p:spPr>
           <a:xfrm xmlns:a="http://schemas.openxmlformats.org/drawingml/2006/main">
             <a:off x="9720000" y="3978000"/>
-            <a:ext cx="900000" cy="251999"/>
+            <a:ext cx="900000" cy="270960"/>
           </a:xfrm>
           <a:prstGeom xmlns:a="http://schemas.openxmlformats.org/drawingml/2006/main" prst="rect">
             <a:avLst/>
@@ -19087,7 +18207,7 @@
                 <a:ea typeface="Aptos"/>
                 <a:cs typeface="Aptos"/>
               </a:rPr>
-              <a:t>15%</a:t>
+              <a:t>15 б.</a:t>
             </a:r>
           </a:p>
         </p:txBody>
@@ -19212,7 +18332,7 @@
         <p:spPr>
           <a:xfrm xmlns:a="http://schemas.openxmlformats.org/drawingml/2006/main">
             <a:off x="9720000" y="4572000"/>
-            <a:ext cx="900000" cy="251999"/>
+            <a:ext cx="900000" cy="270960"/>
           </a:xfrm>
           <a:prstGeom xmlns:a="http://schemas.openxmlformats.org/drawingml/2006/main" prst="rect">
             <a:avLst/>
@@ -19240,7 +18360,7 @@
                 <a:ea typeface="Aptos"/>
                 <a:cs typeface="Aptos"/>
               </a:rPr>
-              <a:t>10%</a:t>
+              <a:t>10 б.</a:t>
             </a:r>
           </a:p>
         </p:txBody>
@@ -19315,7 +18435,7 @@
         <p:spPr>
           <a:xfrm xmlns:a="http://schemas.openxmlformats.org/drawingml/2006/main">
             <a:off x="5220000" y="5472000"/>
-            <a:ext cx="5940000" cy="484320"/>
+            <a:ext cx="5940000" cy="697680"/>
           </a:xfrm>
           <a:prstGeom xmlns:a="http://schemas.openxmlformats.org/drawingml/2006/main" prst="rect">
             <a:avLst/>
@@ -19344,7 +18464,8 @@
                 <a:cs typeface="Aptos"/>
               </a:rPr>
               <a:t>ДЗ · 20 человек · 180 минут
-Слот: 4 мин доклад + 2 мин вопросы + 2 мин показ</a:t>
+Слот: 4 мин доклад + 2 мин вопросы + 2 мин показ
+Шкала: 50–69 — 3 · 70–85 — 4 · 86–100 — 5</a:t>
             </a:r>
           </a:p>
         </p:txBody>

</xml_diff>